<commit_message>
Mise à jour de certaines tournures de phrases
</commit_message>
<xml_diff>
--- a/_slides/remanies/03. TMP_slides.pptx
+++ b/_slides/remanies/03. TMP_slides.pptx
@@ -1014,7 +1014,7 @@
           <a:p>
             <a:r>
               <a:rPr lang="fr-BE"/>
-              <a:t>Aucune de ces méthodes ne modifie la date d'origine : plusDays ou minus rendent une nouvelle date. La section 3 y revient.</a:t>
+              <a:t>Aucune de ces méthodes ne modifie la date d'origine : plusDays ou minus retournent une nouvelle date. La section 3 y revient.</a:t>
             </a:r>
           </a:p>
           <a:p>
@@ -1501,7 +1501,7 @@
           <a:lstStyle/>
           <a:p>
             <a:r>
-              <a:t>La tournure surprend : c'est l'unité qui porte la méthode </a:t>
+              <a:t>La tournure surprend : c'est l'unité qui contient la méthode </a:t>
             </a:r>
             <a:r>
               <a:rPr>
@@ -15886,7 +15886,7 @@
             </a:pPr>
             <a:r>
               <a:rPr sz="2800"/>
-              <a:t>L'unité porte la méthode, pas l'inverse</a:t>
+              <a:t>L'unité contient la méthode, pas l'inverse</a:t>
             </a:r>
           </a:p>
           <a:p>

</xml_diff>